<commit_message>
Add teacher demo code snippet to W1L4 I Do slide
</commit_message>
<xml_diff>
--- a/resources/week-01/W1L4 - Building Your First HTML File.pptx
+++ b/resources/week-01/W1L4 - Building Your First HTML File.pptx
@@ -5087,6 +5087,317 @@
           </a:p>
         </p:txBody>
       </p:sp>
+      <p:sp>
+        <p:nvSpPr>
+          <p:cNvPr id="12" name="Text 8"/>
+          <p:cNvSpPr/>
+          <p:nvPr/>
+        </p:nvSpPr>
+        <p:spPr>
+          <a:xfrm>
+            <a:off x="2880360" y="2193912"/>
+            <a:ext cx="5760720" cy="228600"/>
+          </a:xfrm>
+          <a:prstGeom prst="rect">
+            <a:avLst/>
+          </a:prstGeom>
+          <a:noFill/>
+          <a:ln/>
+        </p:spPr>
+        <p:txBody>
+          <a:bodyPr wrap="square" rtlCol="0" anchor="t"/>
+          <a:lstStyle/>
+          <a:p>
+            <a:pPr indent="0" marL="0">
+              <a:buNone/>
+            </a:pPr>
+            <a:r>
+              <a:rPr lang="en-US" sz="1100" i="1" dirty="0">
+                <a:solidFill>
+                  <a:srgbClr val="6B7785"/>
+                </a:solidFill>
+              </a:rPr>
+              <a:t>Example: teacher's index.html</a:t>
+            </a:r>
+            <a:endParaRPr lang="en-US" sz="1100" i="1" dirty="0"/>
+          </a:p>
+        </p:txBody>
+      </p:sp>
+      <p:sp>
+        <p:nvSpPr>
+          <p:cNvPr id="13" name="Shape 9"/>
+          <p:cNvSpPr/>
+          <p:nvPr/>
+        </p:nvSpPr>
+        <p:spPr>
+          <a:xfrm>
+            <a:off x="2880360" y="2468880"/>
+            <a:ext cx="5760720" cy="1706880"/>
+          </a:xfrm>
+          <a:prstGeom prst="roundRect">
+            <a:avLst>
+              <a:gd name="adj" fmla="val 5000"/>
+            </a:avLst>
+          </a:prstGeom>
+          <a:solidFill>
+            <a:srgbClr val="0E2841"/>
+          </a:solidFill>
+          <a:ln w="12700">
+            <a:solidFill>
+              <a:srgbClr val="0E2841"/>
+            </a:solidFill>
+            <a:prstDash val="solid"/>
+          </a:ln>
+        </p:spPr>
+      </p:sp>
+      <p:sp>
+        <p:nvSpPr>
+          <p:cNvPr id="14" name="Text 9"/>
+          <p:cNvSpPr/>
+          <p:nvPr/>
+        </p:nvSpPr>
+        <p:spPr>
+          <a:xfrm>
+            <a:off x="2971800" y="2560320"/>
+            <a:ext cx="5577840" cy="1524000"/>
+          </a:xfrm>
+          <a:prstGeom prst="rect">
+            <a:avLst/>
+          </a:prstGeom>
+          <a:noFill/>
+          <a:ln/>
+        </p:spPr>
+        <p:txBody>
+          <a:bodyPr wrap="square" rtlCol="0" anchor="t">
+            <a:normAutofit/>
+          </a:bodyPr>
+          <a:lstStyle/>
+          <a:p>
+            <a:pPr indent="0" marL="0">
+              <a:lnSpc>
+                <a:spcPts val="1150"/>
+              </a:lnSpc>
+              <a:buNone/>
+            </a:pPr>
+            <a:r>
+              <a:rPr lang="en-US" sz="900" dirty="0">
+                <a:latin typeface="Courier New"/>
+                <a:solidFill>
+                  <a:srgbClr val="CFE8F2"/>
+                </a:solidFill>
+              </a:rPr>
+              <a:t>&lt;!DOCTYPE html&gt;</a:t>
+            </a:r>
+          </a:p>
+          <a:p>
+            <a:pPr indent="0" marL="0">
+              <a:lnSpc>
+                <a:spcPts val="1150"/>
+              </a:lnSpc>
+              <a:buNone/>
+            </a:pPr>
+            <a:r>
+              <a:rPr lang="en-US" sz="900" dirty="0">
+                <a:latin typeface="Courier New"/>
+                <a:solidFill>
+                  <a:srgbClr val="CFE8F2"/>
+                </a:solidFill>
+              </a:rPr>
+              <a:t>&lt;html&gt;</a:t>
+            </a:r>
+          </a:p>
+          <a:p>
+            <a:pPr indent="0" marL="0">
+              <a:lnSpc>
+                <a:spcPts val="1150"/>
+              </a:lnSpc>
+              <a:buNone/>
+            </a:pPr>
+            <a:r>
+              <a:rPr lang="en-US" sz="900" dirty="0">
+                <a:latin typeface="Courier New"/>
+                <a:solidFill>
+                  <a:srgbClr val="CFE8F2"/>
+                </a:solidFill>
+              </a:rPr>
+              <a:t>&lt;head&gt;</a:t>
+            </a:r>
+          </a:p>
+          <a:p>
+            <a:pPr indent="0" marL="0">
+              <a:lnSpc>
+                <a:spcPts val="1150"/>
+              </a:lnSpc>
+              <a:buNone/>
+            </a:pPr>
+            <a:r>
+              <a:rPr lang="en-US" sz="900" dirty="0">
+                <a:latin typeface="Courier New"/>
+                <a:solidFill>
+                  <a:srgbClr val="CFE8F2"/>
+                </a:solidFill>
+              </a:rPr>
+              <a:t xml:space="preserve">  &lt;title&gt;</a:t>
+            </a:r>
+            <a:r>
+              <a:rPr lang="en-US" sz="900" dirty="0">
+                <a:latin typeface="Courier New"/>
+                <a:solidFill>
+                  <a:srgbClr val="FFFFFF"/>
+                </a:solidFill>
+              </a:rPr>
+              <a:t>Ms. Abboud's Page</a:t>
+            </a:r>
+            <a:r>
+              <a:rPr lang="en-US" sz="900" dirty="0">
+                <a:latin typeface="Courier New"/>
+                <a:solidFill>
+                  <a:srgbClr val="CFE8F2"/>
+                </a:solidFill>
+              </a:rPr>
+              <a:t>&lt;/title&gt;</a:t>
+            </a:r>
+          </a:p>
+          <a:p>
+            <a:pPr indent="0" marL="0">
+              <a:lnSpc>
+                <a:spcPts val="1150"/>
+              </a:lnSpc>
+              <a:buNone/>
+            </a:pPr>
+            <a:r>
+              <a:rPr lang="en-US" sz="900" dirty="0">
+                <a:latin typeface="Courier New"/>
+                <a:solidFill>
+                  <a:srgbClr val="CFE8F2"/>
+                </a:solidFill>
+              </a:rPr>
+              <a:t>&lt;/head&gt;</a:t>
+            </a:r>
+          </a:p>
+          <a:p>
+            <a:pPr indent="0" marL="0">
+              <a:lnSpc>
+                <a:spcPts val="1150"/>
+              </a:lnSpc>
+              <a:buNone/>
+            </a:pPr>
+            <a:r>
+              <a:rPr lang="en-US" sz="900" dirty="0">
+                <a:latin typeface="Courier New"/>
+                <a:solidFill>
+                  <a:srgbClr val="CFE8F2"/>
+                </a:solidFill>
+              </a:rPr>
+              <a:t>&lt;body&gt;</a:t>
+            </a:r>
+          </a:p>
+          <a:p>
+            <a:pPr indent="0" marL="0">
+              <a:lnSpc>
+                <a:spcPts val="1150"/>
+              </a:lnSpc>
+              <a:buNone/>
+            </a:pPr>
+            <a:r>
+              <a:rPr lang="en-US" sz="900" dirty="0">
+                <a:latin typeface="Courier New"/>
+                <a:solidFill>
+                  <a:srgbClr val="CFE8F2"/>
+                </a:solidFill>
+              </a:rPr>
+              <a:t xml:space="preserve">  &lt;h1&gt;</a:t>
+            </a:r>
+            <a:r>
+              <a:rPr lang="en-US" sz="900" dirty="0">
+                <a:latin typeface="Courier New"/>
+                <a:solidFill>
+                  <a:srgbClr val="FFFFFF"/>
+                </a:solidFill>
+              </a:rPr>
+              <a:t>Hello, I'm Ms. Abboud</a:t>
+            </a:r>
+            <a:r>
+              <a:rPr lang="en-US" sz="900" dirty="0">
+                <a:latin typeface="Courier New"/>
+                <a:solidFill>
+                  <a:srgbClr val="CFE8F2"/>
+                </a:solidFill>
+              </a:rPr>
+              <a:t>&lt;/h1&gt;</a:t>
+            </a:r>
+          </a:p>
+          <a:p>
+            <a:pPr indent="0" marL="0">
+              <a:lnSpc>
+                <a:spcPts val="1150"/>
+              </a:lnSpc>
+              <a:buNone/>
+            </a:pPr>
+            <a:r>
+              <a:rPr lang="en-US" sz="900" dirty="0">
+                <a:latin typeface="Courier New"/>
+                <a:solidFill>
+                  <a:srgbClr val="CFE8F2"/>
+                </a:solidFill>
+              </a:rPr>
+              <a:t xml:space="preserve">  &lt;p&gt;</a:t>
+            </a:r>
+            <a:r>
+              <a:rPr lang="en-US" sz="900" dirty="0">
+                <a:latin typeface="Courier New"/>
+                <a:solidFill>
+                  <a:srgbClr val="FFFFFF"/>
+                </a:solidFill>
+              </a:rPr>
+              <a:t>I teach Design 1 and love building things with code.</a:t>
+            </a:r>
+            <a:r>
+              <a:rPr lang="en-US" sz="900" dirty="0">
+                <a:latin typeface="Courier New"/>
+                <a:solidFill>
+                  <a:srgbClr val="CFE8F2"/>
+                </a:solidFill>
+              </a:rPr>
+              <a:t>&lt;/p&gt;</a:t>
+            </a:r>
+          </a:p>
+          <a:p>
+            <a:pPr indent="0" marL="0">
+              <a:lnSpc>
+                <a:spcPts val="1150"/>
+              </a:lnSpc>
+              <a:buNone/>
+            </a:pPr>
+            <a:r>
+              <a:rPr lang="en-US" sz="900" dirty="0">
+                <a:latin typeface="Courier New"/>
+                <a:solidFill>
+                  <a:srgbClr val="CFE8F2"/>
+                </a:solidFill>
+              </a:rPr>
+              <a:t>&lt;/body&gt;</a:t>
+            </a:r>
+          </a:p>
+          <a:p>
+            <a:pPr indent="0" marL="0">
+              <a:lnSpc>
+                <a:spcPts val="1150"/>
+              </a:lnSpc>
+              <a:buNone/>
+            </a:pPr>
+            <a:r>
+              <a:rPr lang="en-US" sz="900" dirty="0">
+                <a:latin typeface="Courier New"/>
+                <a:solidFill>
+                  <a:srgbClr val="CFE8F2"/>
+                </a:solidFill>
+              </a:rPr>
+              <a:t>&lt;/html&gt;</a:t>
+            </a:r>
+          </a:p>
+        </p:txBody>
+      </p:sp>
     </p:spTree>
   </p:cSld>
   <p:clrMapOvr>

</xml_diff>